<commit_message>
Slides: show the demand-level confusion matrix on slide 3
</commit_message>
<xml_diff>
--- a/presentation/team_teamdev_slides.pptx
+++ b/presentation/team_teamdev_slides.pptx
@@ -116,36 +116,36 @@
   <p:extLst>
     <p:ext uri="{521415D9-36F7-43E2-AB2F-B90AF26B5E84}">
       <p14:sectionLst xmlns:p14="http://schemas.microsoft.com/office/powerpoint/2010/main">
-        <p14:section name="Introduction" id="{3a6b4415-61ee-3890-0c9a-066be457b23d}">
+        <p14:section name="Introduction" id="{f3f7c402-28ea-848a-e819-fd45445fe3fc}">
           <p14:sldIdLst>
             <p14:sldId id="256"/>
             <p14:sldId id="257"/>
           </p14:sldIdLst>
         </p14:section>
-        <p14:section name="Data" id="{dce2016c-8995-d460-a3e8-aceb572f7b5d}">
+        <p14:section name="Data" id="{869e7a7e-0007-07b2-cf2b-806a3285990f}">
           <p14:sldIdLst>
             <p14:sldId id="258"/>
           </p14:sldIdLst>
         </p14:section>
-        <p14:section name="Approach" id="{5c8fe162-f798-6752-b26a-be163aabf77e}">
+        <p14:section name="Approach" id="{3869bf84-fd4f-4227-fd3e-19052e86a74e}">
           <p14:sldIdLst>
             <p14:sldId id="259"/>
             <p14:sldId id="260"/>
           </p14:sldIdLst>
         </p14:section>
-        <p14:section name="What the data says" id="{71278326-a514-db33-dff7-b58393ef63c6}">
+        <p14:section name="What the data says" id="{30e7f948-3882-0f35-e521-a8a461d5b432}">
           <p14:sldIdLst>
             <p14:sldId id="261"/>
             <p14:sldId id="262"/>
           </p14:sldIdLst>
         </p14:section>
-        <p14:section name="Results" id="{d31f6e68-67b3-fb38-318f-4a492beb33d4}">
+        <p14:section name="Results" id="{ea65f0c1-9228-d7da-0d88-3c1c4f541575}">
           <p14:sldIdLst>
             <p14:sldId id="263"/>
             <p14:sldId id="264"/>
           </p14:sldIdLst>
         </p14:section>
-        <p14:section name="Close" id="{6763f2b8-aa6c-231c-8ca4-2a1a8db8181b}">
+        <p14:section name="Close" id="{5033f62a-5783-dd85-bccc-5f559676fa5d}">
           <p14:sldIdLst>
             <p14:sldId id="265"/>
           </p14:sldIdLst>
@@ -818,7 +818,7 @@
           <a:p>
             <a:r>
               <a:rPr lang="en-US" dirty="0"/>
-              <a:t>Four inputs. Trips: 85,460 hourly rows for 12 zones from January to October. The forecast grid: 4,032 zone-hours in November. Hourly weather in UTC, and an events calendar of 165 events. Fares, waits and active drivers exist in history but are not known in advance, so we never use them as inputs.</a:t>
+              <a:t>Four inputs. Trips: 85,460 hourly rows for 12 zones from January to October. The forecast grid: 4,032 zone-hours in November. Hourly weather in UTC, and an events calendar of 165 events. Fares, waits and active drivers exist in history but are not known in advance, so we never use them as inputs. The chart on the right sorts every zone-hour into Quiet, Normal, Busy or Peak and shows how often our forecast lands in the right level: 78%, against 73% for the simple baseline.</a:t>
             </a:r>
             <a:endParaRPr lang="en-US" dirty="0"/>
           </a:p>
@@ -5626,7 +5626,7 @@
                   <a:schemeClr val="accent1"/>
                 </a:solidFill>
               </a:rPr>
-              <a:t>WHAT THE TRIP DATA LOOKS LIKE</a:t>
+              <a:t>HOW WELL THE FORECAST CALLS DEMAND LEVELS</a:t>
             </a:r>
             <a:endParaRPr lang="en-US" sz="1100" dirty="0"/>
           </a:p>
@@ -5634,7 +5634,7 @@
       </p:sp>
       <p:pic>
         <p:nvPicPr>
-          <p:cNvPr id="17" name="fig04 hour by weekday heatmap" descr="fig04 hour by weekday heatmap">    </p:cNvPr>
+          <p:cNvPr id="17" name="D7 demand-level confusion matrix" descr="D7 demand-level confusion matrix">    </p:cNvPr>
           <p:cNvPicPr>
             <a:picLocks noChangeAspect="1"/>
           </p:cNvPicPr>
@@ -5648,8 +5648,8 @@
         </p:blipFill>
         <p:spPr>
           <a:xfrm>
-            <a:off x="6629400" y="2018306"/>
-            <a:ext cx="5010912" cy="1815548"/>
+            <a:off x="6629400" y="2062350"/>
+            <a:ext cx="5010912" cy="1727460"/>
           </a:xfrm>
           <a:prstGeom prst="rect">
             <a:avLst/>
@@ -5664,7 +5664,7 @@
         </p:nvSpPr>
         <p:spPr>
           <a:xfrm>
-            <a:off x="6629400" y="3950208"/>
+            <a:off x="6629400" y="3886200"/>
             <a:ext cx="5029200" cy="256032"/>
           </a:xfrm>
           <a:prstGeom prst="rect">
@@ -5686,7 +5686,7 @@
                   <a:schemeClr val="accent5"/>
                 </a:solidFill>
               </a:rPr>
-              <a:t>fig04 · Mean trips by hour and weekday: commute peaks on weekdays, later and flatter at weekends.</a:t>
+              <a:t>Confusion matrix, 19,642 out-of-fold zone-hours: 78% in the right level (baseline 73%); 57% of peaks caught, 92% with the upper-range alert.</a:t>
             </a:r>
             <a:endParaRPr lang="en-US" sz="1050" dirty="0"/>
           </a:p>
@@ -5700,7 +5700,7 @@
         </p:nvSpPr>
         <p:spPr>
           <a:xfrm>
-            <a:off x="6629400" y="4434840"/>
+            <a:off x="6629400" y="4617720"/>
             <a:ext cx="1600200" cy="960120"/>
           </a:xfrm>
           <a:prstGeom prst="roundRect">
@@ -5727,7 +5727,7 @@
         </p:nvSpPr>
         <p:spPr>
           <a:xfrm>
-            <a:off x="6793992" y="4507992"/>
+            <a:off x="6793992" y="4690872"/>
             <a:ext cx="1325880" cy="502920"/>
           </a:xfrm>
           <a:prstGeom prst="rect">
@@ -5766,7 +5766,7 @@
         </p:nvSpPr>
         <p:spPr>
           <a:xfrm>
-            <a:off x="6793992" y="5001768"/>
+            <a:off x="6793992" y="5184648"/>
             <a:ext cx="1325880" cy="329184"/>
           </a:xfrm>
           <a:prstGeom prst="rect">
@@ -5802,7 +5802,7 @@
         </p:nvSpPr>
         <p:spPr>
           <a:xfrm>
-            <a:off x="8321040" y="4434840"/>
+            <a:off x="8321040" y="4617720"/>
             <a:ext cx="1600200" cy="960120"/>
           </a:xfrm>
           <a:prstGeom prst="roundRect">
@@ -5829,7 +5829,7 @@
         </p:nvSpPr>
         <p:spPr>
           <a:xfrm>
-            <a:off x="8485632" y="4507992"/>
+            <a:off x="8485632" y="4690872"/>
             <a:ext cx="1325880" cy="502920"/>
           </a:xfrm>
           <a:prstGeom prst="rect">
@@ -5868,7 +5868,7 @@
         </p:nvSpPr>
         <p:spPr>
           <a:xfrm>
-            <a:off x="8485632" y="5001768"/>
+            <a:off x="8485632" y="5184648"/>
             <a:ext cx="1325880" cy="329184"/>
           </a:xfrm>
           <a:prstGeom prst="rect">
@@ -5904,7 +5904,7 @@
         </p:nvSpPr>
         <p:spPr>
           <a:xfrm>
-            <a:off x="10012680" y="4434840"/>
+            <a:off x="10012680" y="4617720"/>
             <a:ext cx="1627632" cy="960120"/>
           </a:xfrm>
           <a:prstGeom prst="roundRect">
@@ -5931,7 +5931,7 @@
         </p:nvSpPr>
         <p:spPr>
           <a:xfrm>
-            <a:off x="10177272" y="4507992"/>
+            <a:off x="10177272" y="4690872"/>
             <a:ext cx="1353312" cy="502920"/>
           </a:xfrm>
           <a:prstGeom prst="rect">
@@ -5970,7 +5970,7 @@
         </p:nvSpPr>
         <p:spPr>
           <a:xfrm>
-            <a:off x="10177272" y="5001768"/>
+            <a:off x="10177272" y="5184648"/>
             <a:ext cx="1353312" cy="329184"/>
           </a:xfrm>
           <a:prstGeom prst="rect">
@@ -6006,7 +6006,7 @@
         </p:nvSpPr>
         <p:spPr>
           <a:xfrm>
-            <a:off x="6629400" y="5532120"/>
+            <a:off x="6629400" y="5760720"/>
             <a:ext cx="5029200" cy="274320"/>
           </a:xfrm>
           <a:prstGeom prst="rect">

</xml_diff>